<commit_message>
Update all admin, instructor, lab PDFs, and presentation decks after end-to-end lab walkthrough
</commit_message>
<xml_diff>
--- a/slides/antigravity_retail_workshop_en.pptx
+++ b/slides/antigravity_retail_workshop_en.pptx
@@ -379,7 +379,7 @@
             <a:pPr indent="0" algn="r">
               <a:buNone/>
             </a:pPr>
-            <a:fld id="{6F602BA6-C7A8-4294-A667-A7389769C6F8}" type="slidenum">
+            <a:fld id="{15328FFE-EEEA-44AD-B2F6-CC90E5D64EE6}" type="slidenum">
               <a:rPr lang="en-US" sz="1400" b="0" u="none" strike="noStrike">
                 <a:solidFill>
                   <a:srgbClr val="000000"/>
@@ -553,7 +553,7 @@
               </a:lnSpc>
               <a:buNone/>
             </a:pPr>
-            <a:fld id="{63254A8F-9A2D-4322-B003-9EDFECEABD81}" type="slidenum">
+            <a:fld id="{37CF31B8-0DD5-41AC-94A2-84D789E039A0}" type="slidenum">
               <a:rPr lang="en-US" sz="1200" b="0" u="none" strike="noStrike">
                 <a:solidFill>
                   <a:srgbClr val="000000"/>
@@ -726,7 +726,7 @@
               </a:lnSpc>
               <a:buNone/>
             </a:pPr>
-            <a:fld id="{C2BC88EA-1845-462B-9A56-A5721537D649}" type="slidenum">
+            <a:fld id="{3404EC13-959E-4020-9AE9-F77A125C739A}" type="slidenum">
               <a:rPr lang="en-US" sz="1200" b="0" u="none" strike="noStrike">
                 <a:solidFill>
                   <a:srgbClr val="000000"/>
@@ -899,7 +899,7 @@
               </a:lnSpc>
               <a:buNone/>
             </a:pPr>
-            <a:fld id="{F58AD630-894A-49B2-89C9-560E3013B75A}" type="slidenum">
+            <a:fld id="{F0B77B7F-F1B9-4EAA-B157-D614EE61E864}" type="slidenum">
               <a:rPr lang="en-US" sz="1200" b="0" u="none" strike="noStrike">
                 <a:solidFill>
                   <a:srgbClr val="000000"/>
@@ -1072,7 +1072,7 @@
               </a:lnSpc>
               <a:buNone/>
             </a:pPr>
-            <a:fld id="{5683ADB8-1F27-49F4-8CD0-52D94B0C4499}" type="slidenum">
+            <a:fld id="{196036FB-5F8E-4935-BE78-3BF616B5E356}" type="slidenum">
               <a:rPr lang="en-US" sz="1200" b="0" u="none" strike="noStrike">
                 <a:solidFill>
                   <a:srgbClr val="000000"/>
@@ -1245,7 +1245,7 @@
               </a:lnSpc>
               <a:buNone/>
             </a:pPr>
-            <a:fld id="{00779C81-264C-42B8-82ED-2136D309CFD9}" type="slidenum">
+            <a:fld id="{6BE13ED7-592B-4700-BEDA-A48A8D9CC214}" type="slidenum">
               <a:rPr lang="en-US" sz="1200" b="0" u="none" strike="noStrike">
                 <a:solidFill>
                   <a:srgbClr val="000000"/>
@@ -1418,7 +1418,7 @@
               </a:lnSpc>
               <a:buNone/>
             </a:pPr>
-            <a:fld id="{DECCC9B5-8960-4271-9713-BF7CC7CD9037}" type="slidenum">
+            <a:fld id="{6037889C-873A-4EF5-BBA7-8D8CEA15CA6B}" type="slidenum">
               <a:rPr lang="en-US" sz="1200" b="0" u="none" strike="noStrike">
                 <a:solidFill>
                   <a:srgbClr val="000000"/>
@@ -1591,7 +1591,7 @@
               </a:lnSpc>
               <a:buNone/>
             </a:pPr>
-            <a:fld id="{445C5600-8191-47E4-B904-B362CC3027C1}" type="slidenum">
+            <a:fld id="{47A24EF5-3209-44B3-B9C7-B4C6D2FA1C94}" type="slidenum">
               <a:rPr lang="en-US" sz="1200" b="0" u="none" strike="noStrike">
                 <a:solidFill>
                   <a:srgbClr val="000000"/>
@@ -1764,7 +1764,7 @@
               </a:lnSpc>
               <a:buNone/>
             </a:pPr>
-            <a:fld id="{5AD48272-6BA1-4396-8B0B-8E8E1B0BB700}" type="slidenum">
+            <a:fld id="{C10D9F06-FAF0-4FE2-BC2C-FE2759FB4D19}" type="slidenum">
               <a:rPr lang="en-US" sz="1200" b="0" u="none" strike="noStrike">
                 <a:solidFill>
                   <a:srgbClr val="000000"/>
@@ -1937,7 +1937,7 @@
               </a:lnSpc>
               <a:buNone/>
             </a:pPr>
-            <a:fld id="{321A1B55-77A9-4A91-BF90-5E633D14B2CE}" type="slidenum">
+            <a:fld id="{21A7C391-8CC7-46DB-AD74-4D237781444F}" type="slidenum">
               <a:rPr lang="en-US" sz="1200" b="0" u="none" strike="noStrike">
                 <a:solidFill>
                   <a:srgbClr val="000000"/>
@@ -2110,7 +2110,7 @@
               </a:lnSpc>
               <a:buNone/>
             </a:pPr>
-            <a:fld id="{6A5ED100-99B4-49C8-B88C-C57A4F2227B0}" type="slidenum">
+            <a:fld id="{B5444DCA-668B-4B72-A6C6-412C5985B2A5}" type="slidenum">
               <a:rPr lang="en-US" sz="1200" b="0" u="none" strike="noStrike">
                 <a:solidFill>
                   <a:srgbClr val="000000"/>
@@ -2283,7 +2283,7 @@
               </a:lnSpc>
               <a:buNone/>
             </a:pPr>
-            <a:fld id="{B4C72247-8FCF-4B93-A372-18677EED811D}" type="slidenum">
+            <a:fld id="{DBC9599B-C7E3-49E3-9D7D-19195899C0F5}" type="slidenum">
               <a:rPr lang="en-US" sz="1200" b="0" u="none" strike="noStrike">
                 <a:solidFill>
                   <a:srgbClr val="000000"/>
@@ -2456,7 +2456,7 @@
               </a:lnSpc>
               <a:buNone/>
             </a:pPr>
-            <a:fld id="{96DEA573-B4B2-4F9A-9D4E-A3313B1C63AB}" type="slidenum">
+            <a:fld id="{15DB5290-DAC6-472A-8DA4-DB6D8EC4194F}" type="slidenum">
               <a:rPr lang="en-US" sz="1200" b="0" u="none" strike="noStrike">
                 <a:solidFill>
                   <a:srgbClr val="000000"/>
@@ -2629,7 +2629,7 @@
               </a:lnSpc>
               <a:buNone/>
             </a:pPr>
-            <a:fld id="{234972C3-21A6-43AD-B715-C94F151D6091}" type="slidenum">
+            <a:fld id="{E55BED00-BB02-4B50-99B3-39041D1BFA95}" type="slidenum">
               <a:rPr lang="en-US" sz="1200" b="0" u="none" strike="noStrike">
                 <a:solidFill>
                   <a:srgbClr val="000000"/>
@@ -2802,7 +2802,7 @@
               </a:lnSpc>
               <a:buNone/>
             </a:pPr>
-            <a:fld id="{44A3A016-5679-44A5-8AB7-0599F99B6179}" type="slidenum">
+            <a:fld id="{4ADBC43C-CBAE-4B33-A5C2-E5205E52835C}" type="slidenum">
               <a:rPr lang="en-US" sz="1200" b="0" u="none" strike="noStrike">
                 <a:solidFill>
                   <a:srgbClr val="000000"/>
@@ -2975,7 +2975,7 @@
               </a:lnSpc>
               <a:buNone/>
             </a:pPr>
-            <a:fld id="{9A609EFB-458B-4402-94EB-04F06A43EF54}" type="slidenum">
+            <a:fld id="{BCBA1EBF-D2AF-46F3-A56A-9DAC25FFFC1A}" type="slidenum">
               <a:rPr lang="en-US" sz="1200" b="0" u="none" strike="noStrike">
                 <a:solidFill>
                   <a:srgbClr val="000000"/>
@@ -3292,7 +3292,7 @@
               </a:lnSpc>
               <a:buNone/>
             </a:pPr>
-            <a:fld id="{60F18F3F-3485-4BAB-AAB9-7E8D04E065FA}" type="slidenum">
+            <a:fld id="{93DEBC8F-BE94-4CCE-80D7-B41474F9230E}" type="slidenum">
               <a:rPr lang="en-US" sz="1200" b="0" u="none" strike="noStrike">
                 <a:solidFill>
                   <a:schemeClr val="dk1">
@@ -4001,7 +4001,7 @@
               </a:lnSpc>
               <a:buNone/>
             </a:pPr>
-            <a:fld id="{20D4E40D-65C9-42D9-B19D-A67F82E87DB6}" type="slidenum">
+            <a:fld id="{9EEDF19D-01A9-4ACF-AF05-ADD01E778AE7}" type="slidenum">
               <a:rPr lang="en-US" sz="1200" b="0" u="none" strike="noStrike">
                 <a:solidFill>
                   <a:schemeClr val="dk1">
@@ -4796,7 +4796,7 @@
               </a:lnSpc>
               <a:buNone/>
             </a:pPr>
-            <a:fld id="{ABB86F56-E462-4CAC-A56E-D76026CC51D3}" type="slidenum">
+            <a:fld id="{FAF64F76-1D31-4B92-94A7-FA935A480D86}" type="slidenum">
               <a:rPr lang="en-US" sz="1200" b="0" u="none" strike="noStrike">
                 <a:solidFill>
                   <a:schemeClr val="dk1">
@@ -5421,7 +5421,7 @@
               </a:lnSpc>
               <a:buNone/>
             </a:pPr>
-            <a:fld id="{13D08329-8A0E-4715-A1E2-1190B535577B}" type="slidenum">
+            <a:fld id="{3AB47CCF-0193-4C18-A344-54B1D8E67B50}" type="slidenum">
               <a:rPr lang="en-US" sz="1200" b="0" u="none" strike="noStrike">
                 <a:solidFill>
                   <a:schemeClr val="dk1">
@@ -6046,7 +6046,7 @@
               </a:lnSpc>
               <a:buNone/>
             </a:pPr>
-            <a:fld id="{88084C63-A118-442F-BB73-F720923B804F}" type="slidenum">
+            <a:fld id="{CB263D13-04A5-4061-A89E-6895FE0BA9EB}" type="slidenum">
               <a:rPr lang="en-US" sz="1200" b="0" u="none" strike="noStrike">
                 <a:solidFill>
                   <a:schemeClr val="dk1">
@@ -6671,7 +6671,7 @@
               </a:lnSpc>
               <a:buNone/>
             </a:pPr>
-            <a:fld id="{24CD723B-5995-49CB-8A89-DD4444C719C1}" type="slidenum">
+            <a:fld id="{A418F534-C854-4C6D-8150-9BA5FB5489E7}" type="slidenum">
               <a:rPr lang="en-US" sz="1200" b="0" u="none" strike="noStrike">
                 <a:solidFill>
                   <a:schemeClr val="dk1">
@@ -7080,7 +7080,7 @@
               </a:lnSpc>
               <a:buNone/>
             </a:pPr>
-            <a:fld id="{2CDB7CA5-2641-4E6F-962F-F1D0F6B00D4C}" type="slidenum">
+            <a:fld id="{2E5E93DA-2E1B-4758-AA4C-DC3D555F5B7E}" type="slidenum">
               <a:rPr lang="en-US" sz="1200" b="0" u="none" strike="noStrike">
                 <a:solidFill>
                   <a:schemeClr val="dk1">
@@ -8011,7 +8011,7 @@
               </a:lnSpc>
               <a:buNone/>
             </a:pPr>
-            <a:fld id="{C5F37162-A87B-492E-AD07-687B27301786}" type="slidenum">
+            <a:fld id="{FD686A77-28ED-4EBF-B6D3-1485D081EA6C}" type="slidenum">
               <a:rPr lang="en-US" sz="1200" b="0" u="none" strike="noStrike">
                 <a:solidFill>
                   <a:schemeClr val="dk1">
@@ -9170,7 +9170,7 @@
               </a:lnSpc>
               <a:buNone/>
             </a:pPr>
-            <a:fld id="{C18D11F7-4503-416A-8363-253B209813C1}" type="slidenum">
+            <a:fld id="{787A8E79-9B99-4A0E-8B93-911E6B96745E}" type="slidenum">
               <a:rPr lang="en-US" sz="1200" b="0" u="none" strike="noStrike">
                 <a:solidFill>
                   <a:schemeClr val="dk1">
@@ -9489,7 +9489,7 @@
               </a:lnSpc>
               <a:buNone/>
             </a:pPr>
-            <a:fld id="{1854F64C-7B35-48B2-82C3-B61586DF55A8}" type="slidenum">
+            <a:fld id="{E89234B3-856B-4563-85DD-7AE99FF20E0E}" type="slidenum">
               <a:rPr lang="en-US" sz="1200" b="0" u="none" strike="noStrike">
                 <a:solidFill>
                   <a:schemeClr val="dk1">
@@ -9736,7 +9736,7 @@
               </a:lnSpc>
               <a:buNone/>
             </a:pPr>
-            <a:fld id="{2D29EA62-7262-4937-AB54-E51C4F810BD5}" type="slidenum">
+            <a:fld id="{9ED855C7-3CA0-407A-9673-BB0DE56F3A60}" type="slidenum">
               <a:rPr lang="en-US" sz="1200" b="0" u="none" strike="noStrike">
                 <a:solidFill>
                   <a:schemeClr val="dk1">
@@ -11027,7 +11027,7 @@
                 <a:uFillTx/>
                 <a:latin typeface="Arial"/>
               </a:rPr>
-              <a:t> Stop $35,113.25 margin bleed, rescue 35 VIP orders &amp; claim $98,250 OTIF penalties</a:t>
+              <a:t> Stop $18,420.50 margin bleed, rescue 35 VIP orders ($749.3K LTV) &amp; claim $98,250 OTIF</a:t>
             </a:r>
             <a:endParaRPr lang="en-US" sz="1100" b="0" u="none" strike="noStrike">
               <a:solidFill>
@@ -12677,7 +12677,7 @@
                 <a:uFillTx/>
                 <a:latin typeface="Arial"/>
               </a:rPr>
-              <a:t> Intercept every file-edit and shell tool call with a </a:t>
+              <a:t> Intercept every file-edit and shell tool call with </a:t>
             </a:r>
             <a:r>
               <a:rPr lang="en-US" sz="1100" b="1" u="none" strike="noStrike">
@@ -12699,7 +12699,7 @@
                 <a:uFillTx/>
                 <a:latin typeface="Arial"/>
               </a:rPr>
-              <a:t> hook that hard-blocks disabling the </a:t>
+              <a:t> &amp; </a:t>
             </a:r>
             <a:r>
               <a:rPr lang="en-US" sz="1100" b="1" u="none" strike="noStrike">
@@ -12710,7 +12710,7 @@
                 <a:uFillTx/>
                 <a:latin typeface="Courier New"/>
               </a:rPr>
-              <a:t>15%</a:t>
+              <a:t>PostToolUse</a:t>
             </a:r>
             <a:r>
               <a:rPr lang="en-US" sz="1100" b="0" u="none" strike="noStrike">
@@ -12721,7 +12721,29 @@
                 <a:uFillTx/>
                 <a:latin typeface="Arial"/>
               </a:rPr>
-              <a:t> margin floor (</a:t>
+              <a:t> hooks that hard-block disabling </a:t>
+            </a:r>
+            <a:r>
+              <a:rPr lang="en-US" sz="1100" b="1" u="none" strike="noStrike">
+                <a:solidFill>
+                  <a:srgbClr val="20E3B2"/>
+                </a:solidFill>
+                <a:effectLst/>
+                <a:uFillTx/>
+                <a:latin typeface="Courier New"/>
+              </a:rPr>
+              <a:t>margin_floor_pct</a:t>
+            </a:r>
+            <a:r>
+              <a:rPr lang="en-US" sz="1100" b="0" u="none" strike="noStrike">
+                <a:solidFill>
+                  <a:srgbClr val="F0F6FC"/>
+                </a:solidFill>
+                <a:effectLst/>
+                <a:uFillTx/>
+                <a:latin typeface="Arial"/>
+              </a:rPr>
+              <a:t> or destructive SQL (</a:t>
             </a:r>
             <a:r>
               <a:rPr lang="en-US" sz="1100" b="1" u="none" strike="noStrike">
@@ -13054,6 +13076,28 @@
                 <a:uFillTx/>
                 <a:latin typeface="Arial"/>
               </a:rPr>
+              <a:t> &amp; </a:t>
+            </a:r>
+            <a:r>
+              <a:rPr lang="en-US" sz="1100" b="1" u="none" strike="noStrike">
+                <a:solidFill>
+                  <a:srgbClr val="20E3B2"/>
+                </a:solidFill>
+                <a:effectLst/>
+                <a:uFillTx/>
+                <a:latin typeface="Courier New"/>
+              </a:rPr>
+              <a:t>PostToolUse</a:t>
+            </a:r>
+            <a:r>
+              <a:rPr lang="en-US" sz="1100" b="0" u="none" strike="noStrike">
+                <a:solidFill>
+                  <a:srgbClr val="F0F6FC"/>
+                </a:solidFill>
+                <a:effectLst/>
+                <a:uFillTx/>
+                <a:latin typeface="Arial"/>
+              </a:rPr>
               <a:t> guardrail blocking </a:t>
             </a:r>
             <a:r>
@@ -13065,7 +13109,7 @@
                 <a:uFillTx/>
                 <a:latin typeface="Courier New"/>
               </a:rPr>
-              <a:t>enforce_floor=False</a:t>
+              <a:t>margin_floor_pct = 0.0</a:t>
             </a:r>
             <a:r>
               <a:rPr lang="en-US" sz="1100" b="0" u="none" strike="noStrike">
@@ -13076,7 +13120,7 @@
                 <a:uFillTx/>
                 <a:latin typeface="Arial"/>
               </a:rPr>
-              <a:t>, margin </a:t>
+              <a:t>, </a:t>
             </a:r>
             <a:r>
               <a:rPr lang="en-US" sz="1100" b="1" u="none" strike="noStrike">
@@ -13087,7 +13131,7 @@
                 <a:uFillTx/>
                 <a:latin typeface="Courier New"/>
               </a:rPr>
-              <a:t>&lt; 0.15</a:t>
+              <a:t>DISABLE_MARGIN_FLOOR</a:t>
             </a:r>
             <a:r>
               <a:rPr lang="en-US" sz="1100" b="0" u="none" strike="noStrike">
@@ -13215,7 +13259,29 @@
                 <a:uFillTx/>
                 <a:latin typeface="Arial"/>
               </a:rPr>
-              <a:t> Pass all 5 MCP &amp; Hook tests in </a:t>
+              <a:t> Pass all 3 Lab 03 MCP &amp; Hook tests (</a:t>
+            </a:r>
+            <a:r>
+              <a:rPr lang="en-US" sz="1100" b="1" u="none" strike="noStrike">
+                <a:solidFill>
+                  <a:srgbClr val="20E3B2"/>
+                </a:solidFill>
+                <a:effectLst/>
+                <a:uFillTx/>
+                <a:latin typeface="Courier New"/>
+              </a:rPr>
+              <a:t>13 passed</a:t>
+            </a:r>
+            <a:r>
+              <a:rPr lang="en-US" sz="1100" b="0" u="none" strike="noStrike">
+                <a:solidFill>
+                  <a:srgbClr val="F0F6FC"/>
+                </a:solidFill>
+                <a:effectLst/>
+                <a:uFillTx/>
+                <a:latin typeface="Arial"/>
+              </a:rPr>
+              <a:t> cumulative) in </a:t>
             </a:r>
             <a:r>
               <a:rPr lang="en-US" sz="1100" b="1" u="none" strike="noStrike">
@@ -14031,7 +14097,7 @@
                 <a:uFillTx/>
                 <a:latin typeface="Courier New"/>
               </a:rPr>
-              <a:t>simulate_promo_margin_guard(promo_code, category, loyalty_tier)</a:t>
+              <a:t>audit_vendor_otif_contracts(only_breaching=True)</a:t>
             </a:r>
             <a:r>
               <a:rPr lang="en-US" sz="1100" b="0" u="none" strike="noStrike">
@@ -14042,7 +14108,7 @@
                 <a:uFillTx/>
                 <a:latin typeface="Arial"/>
               </a:rPr>
-              <a:t> and </a:t>
+              <a:t>, </a:t>
             </a:r>
             <a:r>
               <a:rPr lang="en-US" sz="1100" b="1" u="none" strike="noStrike">
@@ -14053,7 +14119,29 @@
                 <a:uFillTx/>
                 <a:latin typeface="Courier New"/>
               </a:rPr>
-              <a:t>list_at_risk_vip_orders(loyalty_tier, limit)</a:t>
+              <a:t>simulate_promo_margin_guard(sku, qty=1, promo_codes_csv="")</a:t>
+            </a:r>
+            <a:r>
+              <a:rPr lang="en-US" sz="1100" b="0" u="none" strike="noStrike">
+                <a:solidFill>
+                  <a:srgbClr val="F0F6FC"/>
+                </a:solidFill>
+                <a:effectLst/>
+                <a:uFillTx/>
+                <a:latin typeface="Arial"/>
+              </a:rPr>
+              <a:t>, and </a:t>
+            </a:r>
+            <a:r>
+              <a:rPr lang="en-US" sz="1100" b="1" u="none" strike="noStrike">
+                <a:solidFill>
+                  <a:srgbClr val="20E3B2"/>
+                </a:solidFill>
+                <a:effectLst/>
+                <a:uFillTx/>
+                <a:latin typeface="Courier New"/>
+              </a:rPr>
+              <a:t>list_at_risk_vip_orders(loyalty_tier="DIAMOND")</a:t>
             </a:r>
             <a:r>
               <a:rPr lang="en-US" sz="1100" b="0" u="none" strike="noStrike">
@@ -14170,7 +14258,7 @@
                 <a:uFillTx/>
                 <a:latin typeface="Courier New"/>
               </a:rPr>
-              <a:t>.venv/bin/python -m mcp_server.retail_mcp</a:t>
+              <a:t>./.venv/bin/python mcp_server/retail_mcp.py</a:t>
             </a:r>
             <a:r>
               <a:rPr lang="en-US" sz="1100" b="0" u="none" strike="noStrike">
@@ -14181,7 +14269,7 @@
                 <a:uFillTx/>
                 <a:latin typeface="Arial"/>
               </a:rPr>
-              <a:t>.</a:t>
+              <a:t> over stdio.</a:t>
             </a:r>
             <a:endParaRPr lang="en-US" sz="1100" b="0" u="none" strike="noStrike">
               <a:solidFill>
@@ -14276,6 +14364,28 @@
                 <a:uFillTx/>
                 <a:latin typeface="Arial"/>
               </a:rPr>
+              <a:t> and </a:t>
+            </a:r>
+            <a:r>
+              <a:rPr lang="en-US" sz="1100" b="1" u="none" strike="noStrike">
+                <a:solidFill>
+                  <a:srgbClr val="20E3B2"/>
+                </a:solidFill>
+                <a:effectLst/>
+                <a:uFillTx/>
+                <a:latin typeface="Courier New"/>
+              </a:rPr>
+              <a:t>PostToolUse</a:t>
+            </a:r>
+            <a:r>
+              <a:rPr lang="en-US" sz="1100" b="0" u="none" strike="noStrike">
+                <a:solidFill>
+                  <a:srgbClr val="F0F6FC"/>
+                </a:solidFill>
+                <a:effectLst/>
+                <a:uFillTx/>
+                <a:latin typeface="Arial"/>
+              </a:rPr>
               <a:t> to </a:t>
             </a:r>
             <a:r>
@@ -14287,7 +14397,7 @@
                 <a:uFillTx/>
                 <a:latin typeface="Courier New"/>
               </a:rPr>
-              <a:t>scripts/margin_guard_hook.py</a:t>
+              <a:t>./.venv/bin/python scripts/margin_guard_hook.py --phase pre</a:t>
             </a:r>
             <a:r>
               <a:rPr lang="en-US" sz="1100" b="0" u="none" strike="noStrike">
@@ -14298,7 +14408,7 @@
                 <a:uFillTx/>
                 <a:latin typeface="Arial"/>
               </a:rPr>
-              <a:t> (blocks </a:t>
+              <a:t> (and </a:t>
             </a:r>
             <a:r>
               <a:rPr lang="en-US" sz="1100" b="1" u="none" strike="noStrike">
@@ -14309,7 +14419,7 @@
                 <a:uFillTx/>
                 <a:latin typeface="Courier New"/>
               </a:rPr>
-              <a:t>enforce_floor=False</a:t>
+              <a:t>--phase post</a:t>
             </a:r>
             <a:r>
               <a:rPr lang="en-US" sz="1100" b="0" u="none" strike="noStrike">
@@ -14320,29 +14430,7 @@
                 <a:uFillTx/>
                 <a:latin typeface="Arial"/>
               </a:rPr>
-              <a:t> or margin </a:t>
-            </a:r>
-            <a:r>
-              <a:rPr lang="en-US" sz="1100" b="1" u="none" strike="noStrike">
-                <a:solidFill>
-                  <a:srgbClr val="20E3B2"/>
-                </a:solidFill>
-                <a:effectLst/>
-                <a:uFillTx/>
-                <a:latin typeface="Courier New"/>
-              </a:rPr>
-              <a:t>&lt; 0.15</a:t>
-            </a:r>
-            <a:r>
-              <a:rPr lang="en-US" sz="1100" b="0" u="none" strike="noStrike">
-                <a:solidFill>
-                  <a:srgbClr val="F0F6FC"/>
-                </a:solidFill>
-                <a:effectLst/>
-                <a:uFillTx/>
-                <a:latin typeface="Arial"/>
-              </a:rPr>
-              <a:t> with exit code </a:t>
+              <a:t>, blocking policy violations with exit code </a:t>
             </a:r>
             <a:r>
               <a:rPr lang="en-US" sz="1100" b="1" u="none" strike="noStrike">
@@ -14448,7 +14536,7 @@
                 <a:uFillTx/>
                 <a:latin typeface="Courier New"/>
               </a:rPr>
-              <a:t>5 passed</a:t>
+              <a:t>13 passed</a:t>
             </a:r>
             <a:r>
               <a:rPr lang="en-US" sz="1100" b="0" u="none" strike="noStrike">
@@ -14459,7 +14547,7 @@
                 <a:uFillTx/>
                 <a:latin typeface="Arial"/>
               </a:rPr>
-              <a:t> + compliance audit log verified).</a:t>
+              <a:t> cumulative across Labs 01–03 + compliance audit log verified).</a:t>
             </a:r>
             <a:endParaRPr lang="en-US" sz="1100" b="0" u="none" strike="noStrike">
               <a:solidFill>
@@ -14688,7 +14776,7 @@
                 <a:uFillTx/>
                 <a:latin typeface="Arial"/>
               </a:rPr>
-              <a:t> '/plan Implement simulate_promo_margin_guard and list_at_risk_vip_orders in @mcp_server/retail_mcp.py so all tool schemas match @tests/test_lab03_mcp_hooks.py.'</a:t>
+              <a:t> '/plan Implement audit_vendor_otif_contracts, simulate_promo_margin_guard, and list_at_risk_vip_orders in @mcp_server/retail_mcp.py so all tool schemas match @tests/test_lab03_mcp_hooks.py.'</a:t>
             </a:r>
             <a:endParaRPr lang="en-US" sz="1100" b="0" u="none" strike="noStrike">
               <a:solidFill>
@@ -14739,7 +14827,7 @@
                 <a:uFillTx/>
                 <a:latin typeface="Arial"/>
               </a:rPr>
-              <a:t> 'Create @.agents/mcp_config.json for retail-pulse-mcp and @.agents/hooks.json wiring PreToolUse to ./scripts/margin_guard_hook.py.'</a:t>
+              <a:t> 'Create @.agents/mcp_config.json for retail-pulse-mcp and @.agents/hooks.json wiring PreToolUse and PostToolUse to ./scripts/margin_guard_hook.py.'</a:t>
             </a:r>
             <a:endParaRPr lang="en-US" sz="1100" b="0" u="none" strike="noStrike">
               <a:solidFill>
@@ -14801,7 +14889,7 @@
                 <a:uFillTx/>
                 <a:latin typeface="Courier New"/>
               </a:rPr>
-              <a:t>echo '{"tool_name":"edit_file","tool_input":{"Path":"src/services/promo_pricing.py","Replacement":"enforce_floor=False"}}' | .venv/bin/python scripts/margin_guard_hook.py</a:t>
+              <a:t>echo '{"tool_name":"edit_file","tool_input":{"content":"margin_floor_pct = 0.0"}}' | ./.venv/bin/python scripts/margin_guard_hook.py --phase pre</a:t>
             </a:r>
             <a:endParaRPr lang="en-US" sz="1100" b="0" u="none" strike="noStrike">
               <a:solidFill>
@@ -17011,7 +17099,7 @@
                 <a:uFillTx/>
                 <a:latin typeface="Courier New"/>
               </a:rPr>
-              <a:t>evaluate_candidates</a:t>
+              <a:t>optimize_at_risk_order_routing</a:t>
             </a:r>
             <a:r>
               <a:rPr lang="en-US" sz="1100" b="0" u="none" strike="noStrike">
@@ -17033,7 +17121,7 @@
                 <a:uFillTx/>
                 <a:latin typeface="Courier New"/>
               </a:rPr>
-              <a:t>optimize_at_risk_orders</a:t>
+              <a:t>claim_vendor_otif_chargebacks</a:t>
             </a:r>
             <a:r>
               <a:rPr lang="en-US" sz="1100" b="0" u="none" strike="noStrike">
@@ -17044,7 +17132,51 @@
                 <a:uFillTx/>
                 <a:latin typeface="Arial"/>
               </a:rPr>
-              <a:t>) rescuing all 35 VIP orders.</a:t>
+              <a:t>) rescuing all 35 VIP orders (</a:t>
+            </a:r>
+            <a:r>
+              <a:rPr lang="en-US" sz="1100" b="1" u="none" strike="noStrike">
+                <a:solidFill>
+                  <a:srgbClr val="58A6FF"/>
+                </a:solidFill>
+                <a:effectLst/>
+                <a:uFillTx/>
+                <a:latin typeface="Courier New"/>
+              </a:rPr>
+              <a:t>$749,300.00</a:t>
+            </a:r>
+            <a:r>
+              <a:rPr lang="en-US" sz="1100" b="0" u="none" strike="noStrike">
+                <a:solidFill>
+                  <a:srgbClr val="F0F6FC"/>
+                </a:solidFill>
+                <a:effectLst/>
+                <a:uFillTx/>
+                <a:latin typeface="Arial"/>
+              </a:rPr>
+              <a:t> LTV) and claiming </a:t>
+            </a:r>
+            <a:r>
+              <a:rPr lang="en-US" sz="1100" b="1" u="none" strike="noStrike">
+                <a:solidFill>
+                  <a:srgbClr val="58A6FF"/>
+                </a:solidFill>
+                <a:effectLst/>
+                <a:uFillTx/>
+                <a:latin typeface="Courier New"/>
+              </a:rPr>
+              <a:t>$98,250.00</a:t>
+            </a:r>
+            <a:r>
+              <a:rPr lang="en-US" sz="1100" b="0" u="none" strike="noStrike">
+                <a:solidFill>
+                  <a:srgbClr val="F0F6FC"/>
+                </a:solidFill>
+                <a:effectLst/>
+                <a:uFillTx/>
+                <a:latin typeface="Arial"/>
+              </a:rPr>
+              <a:t> OTIF.</a:t>
             </a:r>
             <a:endParaRPr lang="en-US" sz="1100" b="0" u="none" strike="noStrike">
               <a:solidFill>
@@ -18127,7 +18259,7 @@
                 <a:uFillTx/>
                 <a:latin typeface="Courier New"/>
               </a:rPr>
-              <a:t>evaluate_candidates()</a:t>
+              <a:t>optimize_at_risk_order_routing()</a:t>
             </a:r>
             <a:r>
               <a:rPr lang="en-US" sz="1100" b="0" u="none" strike="noStrike">
@@ -18149,7 +18281,7 @@
                 <a:uFillTx/>
                 <a:latin typeface="Courier New"/>
               </a:rPr>
-              <a:t>optimize_at_risk_orders()</a:t>
+              <a:t>claim_vendor_otif_chargebacks()</a:t>
             </a:r>
             <a:r>
               <a:rPr lang="en-US" sz="1100" b="0" u="none" strike="noStrike">
@@ -18182,7 +18314,51 @@
                 <a:uFillTx/>
                 <a:latin typeface="Arial"/>
               </a:rPr>
-              <a:t> (rerouting 35 VIP orders by highest post-shipping net margin).</a:t>
+              <a:t> (rerouting all 35 VIP orders to </a:t>
+            </a:r>
+            <a:r>
+              <a:rPr lang="en-US" sz="1100" b="1" u="none" strike="noStrike">
+                <a:solidFill>
+                  <a:srgbClr val="58A6FF"/>
+                </a:solidFill>
+                <a:effectLst/>
+                <a:uFillTx/>
+                <a:latin typeface="Courier New"/>
+              </a:rPr>
+              <a:t>REROUTED_SAVED</a:t>
+            </a:r>
+            <a:r>
+              <a:rPr lang="en-US" sz="1100" b="0" u="none" strike="noStrike">
+                <a:solidFill>
+                  <a:srgbClr val="F0F6FC"/>
+                </a:solidFill>
+                <a:effectLst/>
+                <a:uFillTx/>
+                <a:latin typeface="Arial"/>
+              </a:rPr>
+              <a:t> and claiming </a:t>
+            </a:r>
+            <a:r>
+              <a:rPr lang="en-US" sz="1100" b="1" u="none" strike="noStrike">
+                <a:solidFill>
+                  <a:srgbClr val="58A6FF"/>
+                </a:solidFill>
+                <a:effectLst/>
+                <a:uFillTx/>
+                <a:latin typeface="Courier New"/>
+              </a:rPr>
+              <a:t>$98,250.00</a:t>
+            </a:r>
+            <a:r>
+              <a:rPr lang="en-US" sz="1100" b="0" u="none" strike="noStrike">
+                <a:solidFill>
+                  <a:srgbClr val="F0F6FC"/>
+                </a:solidFill>
+                <a:effectLst/>
+                <a:uFillTx/>
+                <a:latin typeface="Arial"/>
+              </a:rPr>
+              <a:t>).</a:t>
             </a:r>
             <a:endParaRPr lang="en-US" sz="1100" b="0" u="none" strike="noStrike">
               <a:solidFill>
@@ -18332,7 +18508,7 @@
                 <a:uFillTx/>
                 <a:latin typeface="Courier New"/>
               </a:rPr>
-              <a:t>GET /.well-known/agent.json</a:t>
+              <a:t>get_a2a_agent_card</a:t>
             </a:r>
             <a:r>
               <a:rPr lang="en-US" sz="1100" b="0" u="none" strike="noStrike">
@@ -18354,7 +18530,7 @@
                 <a:uFillTx/>
                 <a:latin typeface="Courier New"/>
               </a:rPr>
-              <a:t>POST /api/v1/a2a</a:t>
+              <a:t>handle_a2a_jsonrpc</a:t>
             </a:r>
             <a:r>
               <a:rPr lang="en-US" sz="1100" b="0" u="none" strike="noStrike">
@@ -18427,7 +18603,7 @@
                 <a:uFillTx/>
                 <a:latin typeface="Courier New"/>
               </a:rPr>
-              <a:t>./scripts/run_adk_web.sh --port 8080</a:t>
+              <a:t>./scripts/run_adk_web.sh</a:t>
             </a:r>
             <a:r>
               <a:rPr lang="en-US" sz="1100" b="0" u="none" strike="noStrike">
@@ -18850,7 +19026,7 @@
                 <a:uFillTx/>
                 <a:latin typeface="Arial"/>
               </a:rPr>
-              <a:t> '/plan Implement evaluate_candidates and optimize_at_risk_orders in @src/services/fulfillment_router.py ranking nodes by (-post_shipping_net_margin_usd, shipping_cost_usd, DC priority).'</a:t>
+              <a:t> '/plan Implement optimize_at_risk_order_routing and claim_vendor_otif_chargebacks in @src/services/fulfillment_router.py ranking candidate nodes by lowest shipping_cost_per_unit and highest true_atp.'</a:t>
             </a:r>
             <a:endParaRPr lang="en-US" sz="1100" b="0" u="none" strike="noStrike">
               <a:solidFill>
@@ -18901,7 +19077,7 @@
                 <a:uFillTx/>
                 <a:latin typeface="Arial"/>
               </a:rPr>
-              <a:t> '/teamwork Implement WMSInventoryATPAgent, MerchandisingMarginOTIFAgent, RetailPulseOrchestratorAgent, build_a2a_agent_card, and handle_a2a_jsonrpc in @src/agents/adk_a2a_orchestrator.py.'</a:t>
+              <a:t> '/teamwork Implement WMSInventoryATPAgent, MerchandisingMarginOTIFAgent, RetailPulseOrchestratorAgent, get_a2a_agent_card, and handle_a2a_jsonrpc in @src/agents/adk_a2a_orchestrator.py.'</a:t>
             </a:r>
             <a:endParaRPr lang="en-US" sz="1100" b="0" u="none" strike="noStrike">
               <a:solidFill>
@@ -18974,7 +19150,7 @@
                 <a:uFillTx/>
                 <a:latin typeface="Arial"/>
               </a:rPr>
-              <a:t> 'Execute omnichannel remediation: enforce 15% margin floor, reroute all 35 VIP orders, and claim OTIF vendor chargebacks.'</a:t>
+              <a:t> 'Execute omnichannel remediation: enforce margin floor across 28 orders, reroute all 35 VIP orders, and claim OTIF vendor chargebacks.'</a:t>
             </a:r>
             <a:endParaRPr lang="en-US" sz="1100" b="0" u="none" strike="noStrike">
               <a:solidFill>
@@ -22723,7 +22899,7 @@
                 <a:uFillTx/>
                 <a:latin typeface="Courier New"/>
               </a:rPr>
-              <a:t>$35,113.25</a:t>
+              <a:t>$18,420.50</a:t>
             </a:r>
             <a:r>
               <a:rPr lang="en-US" sz="1100" b="0" u="none" strike="noStrike">
@@ -22734,7 +22910,7 @@
                 <a:uFillTx/>
                 <a:latin typeface="Arial"/>
               </a:rPr>
-              <a:t> in negative margin bleed across 30 orders and accurately flag 35 </a:t>
+              <a:t> in negative margin bleed across 28 </a:t>
             </a:r>
             <a:r>
               <a:rPr lang="en-US" sz="1100" b="1" u="none" strike="noStrike">
@@ -22745,6 +22921,28 @@
                 <a:uFillTx/>
                 <a:latin typeface="Courier New"/>
               </a:rPr>
+              <a:t>MARGIN_HOLD</a:t>
+            </a:r>
+            <a:r>
+              <a:rPr lang="en-US" sz="1100" b="0" u="none" strike="noStrike">
+                <a:solidFill>
+                  <a:srgbClr val="F0F6FC"/>
+                </a:solidFill>
+                <a:effectLst/>
+                <a:uFillTx/>
+                <a:latin typeface="Arial"/>
+              </a:rPr>
+              <a:t> orders and accurately flag 35 </a:t>
+            </a:r>
+            <a:r>
+              <a:rPr lang="en-US" sz="1100" b="1" u="none" strike="noStrike">
+                <a:solidFill>
+                  <a:srgbClr val="20E3B2"/>
+                </a:solidFill>
+                <a:effectLst/>
+                <a:uFillTx/>
+                <a:latin typeface="Courier New"/>
+              </a:rPr>
               <a:t>DIAMOND</a:t>
             </a:r>
             <a:r>
@@ -22789,7 +22987,7 @@
                 <a:uFillTx/>
                 <a:latin typeface="Courier New"/>
               </a:rPr>
-              <a:t>&gt;$250K</a:t>
+              <a:t>$749,300.00</a:t>
             </a:r>
             <a:r>
               <a:rPr lang="en-US" sz="1100" b="0" u="none" strike="noStrike">
@@ -22928,7 +23126,7 @@
                 <a:uFillTx/>
                 <a:latin typeface="Courier New"/>
               </a:rPr>
-              <a:t>15%</a:t>
+              <a:t>margin_floor_pct</a:t>
             </a:r>
             <a:r>
               <a:rPr lang="en-US" sz="1100" b="0" u="none" strike="noStrike">
@@ -22939,7 +23137,7 @@
                 <a:uFillTx/>
                 <a:latin typeface="Arial"/>
               </a:rPr>
-              <a:t> margin floor.</a:t>
+              <a:t>.</a:t>
             </a:r>
             <a:endParaRPr lang="en-US" sz="1100" b="0" u="none" strike="noStrike">
               <a:solidFill>
@@ -23012,7 +23210,7 @@
                 <a:uFillTx/>
                 <a:latin typeface="Arial"/>
               </a:rPr>
-              <a:t> to compute </a:t>
+              <a:t> (</a:t>
             </a:r>
             <a:r>
               <a:rPr lang="en-US" sz="1100" b="1" u="none" strike="noStrike">
@@ -23023,7 +23221,51 @@
                 <a:uFillTx/>
                 <a:latin typeface="Courier New"/>
               </a:rPr>
-              <a:t>raw_atp = on_hand - reserved - safety_stock - unprocessed_webhook_delta_qty</a:t>
+              <a:t>calculate_true_atp</a:t>
+            </a:r>
+            <a:r>
+              <a:rPr lang="en-US" sz="1100" b="0" u="none" strike="noStrike">
+                <a:solidFill>
+                  <a:srgbClr val="F0F6FC"/>
+                </a:solidFill>
+                <a:effectLst/>
+                <a:uFillTx/>
+                <a:latin typeface="Arial"/>
+              </a:rPr>
+              <a:t> / </a:t>
+            </a:r>
+            <a:r>
+              <a:rPr lang="en-US" sz="1100" b="1" u="none" strike="noStrike">
+                <a:solidFill>
+                  <a:srgbClr val="20E3B2"/>
+                </a:solidFill>
+                <a:effectLst/>
+                <a:uFillTx/>
+                <a:latin typeface="Courier New"/>
+              </a:rPr>
+              <a:t>evaluate_location_atp</a:t>
+            </a:r>
+            <a:r>
+              <a:rPr lang="en-US" sz="1100" b="0" u="none" strike="noStrike">
+                <a:solidFill>
+                  <a:srgbClr val="F0F6FC"/>
+                </a:solidFill>
+                <a:effectLst/>
+                <a:uFillTx/>
+                <a:latin typeface="Arial"/>
+              </a:rPr>
+              <a:t>) to subtract </a:t>
+            </a:r>
+            <a:r>
+              <a:rPr lang="en-US" sz="1100" b="1" u="none" strike="noStrike">
+                <a:solidFill>
+                  <a:srgbClr val="20E3B2"/>
+                </a:solidFill>
+                <a:effectLst/>
+                <a:uFillTx/>
+                <a:latin typeface="Courier New"/>
+              </a:rPr>
+              <a:t>reserved_qty + damaged_hold_qty + bopis_lock_qty + safety_stock_qty + unprocessed_pos_events</a:t>
             </a:r>
             <a:r>
               <a:rPr lang="en-US" sz="1100" b="0" u="none" strike="noStrike">
@@ -23085,7 +23327,7 @@
                 <a:uFillTx/>
                 <a:latin typeface="Arial"/>
               </a:rPr>
-              <a:t> Pass all 5 unit/integration tests in </a:t>
+              <a:t> Pass all 6 unit/integration tests in </a:t>
             </a:r>
             <a:r>
               <a:rPr lang="en-US" sz="1100" b="1" u="none" strike="noStrike">
@@ -24106,7 +24348,7 @@
                 <a:uFillTx/>
                 <a:latin typeface="Courier New"/>
               </a:rPr>
-              <a:t>contract_min_margin_floor_pct</a:t>
+              <a:t>margin_floor_pct</a:t>
             </a:r>
             <a:r>
               <a:rPr lang="en-US" sz="1100" b="0" u="none" strike="noStrike">
@@ -24190,7 +24432,7 @@
                 <a:uFillTx/>
                 <a:latin typeface="Arial"/>
               </a:rPr>
-              <a:t> Compute </a:t>
+              <a:t> Subtract </a:t>
             </a:r>
             <a:r>
               <a:rPr lang="en-US" sz="1100" b="1" u="none" strike="noStrike">
@@ -24201,7 +24443,7 @@
                 <a:uFillTx/>
                 <a:latin typeface="Courier New"/>
               </a:rPr>
-              <a:t>raw_atp = on_hand - reserved - safety_stock - unprocessed_webhook_delta_qty</a:t>
+              <a:t>reserved_qty + damaged_hold_qty + bopis_lock_qty + safety_stock_qty + unprocessed_pos_events</a:t>
             </a:r>
             <a:r>
               <a:rPr lang="en-US" sz="1100" b="0" u="none" strike="noStrike">
@@ -24212,7 +24454,29 @@
                 <a:uFillTx/>
                 <a:latin typeface="Arial"/>
               </a:rPr>
-              <a:t> and </a:t>
+              <a:t> from </a:t>
+            </a:r>
+            <a:r>
+              <a:rPr lang="en-US" sz="1100" b="1" u="none" strike="noStrike">
+                <a:solidFill>
+                  <a:srgbClr val="20E3B2"/>
+                </a:solidFill>
+                <a:effectLst/>
+                <a:uFillTx/>
+                <a:latin typeface="Courier New"/>
+              </a:rPr>
+              <a:t>on_hand_qty</a:t>
+            </a:r>
+            <a:r>
+              <a:rPr lang="en-US" sz="1100" b="0" u="none" strike="noStrike">
+                <a:solidFill>
+                  <a:srgbClr val="F0F6FC"/>
+                </a:solidFill>
+                <a:effectLst/>
+                <a:uFillTx/>
+                <a:latin typeface="Arial"/>
+              </a:rPr>
+              <a:t> and clamp </a:t>
             </a:r>
             <a:r>
               <a:rPr lang="en-US" sz="1100" b="1" u="none" strike="noStrike">
@@ -24318,7 +24582,7 @@
                 <a:uFillTx/>
                 <a:latin typeface="Courier New"/>
               </a:rPr>
-              <a:t>5 passed</a:t>
+              <a:t>6 passed</a:t>
             </a:r>
             <a:r>
               <a:rPr lang="en-US" sz="1100" b="0" u="none" strike="noStrike">
@@ -24340,7 +24604,7 @@
                 <a:uFillTx/>
                 <a:latin typeface="Courier New"/>
               </a:rPr>
-              <a:t>$35,113.25</a:t>
+              <a:t>$18,420.50</a:t>
             </a:r>
             <a:r>
               <a:rPr lang="en-US" sz="1100" b="0" u="none" strike="noStrike">
@@ -24351,7 +24615,7 @@
                 <a:uFillTx/>
                 <a:latin typeface="Arial"/>
               </a:rPr>
-              <a:t> bleed stopped; 35 VIP orders flagged).</a:t>
+              <a:t> bleed stopped across 28 orders; 35 VIP orders flagged).</a:t>
             </a:r>
             <a:endParaRPr lang="en-US" sz="1100" b="0" u="none" strike="noStrike">
               <a:solidFill>
@@ -24580,7 +24844,7 @@
                 <a:uFillTx/>
                 <a:latin typeface="Arial"/>
               </a:rPr>
-              <a:t> '@src/services/promo_pricing.py @src/services/inventory_atp.py @data/logs/pos_wms_webhooks.jsonl @tests/test_lab01_triage.py Run pytest and explain why 30 orders are bleeding margin and 35 VIP orders have phantom ATP.'</a:t>
+              <a:t> '@src/services/promo_pricing.py @src/services/inventory_atp.py @data/logs/pos_wms_webhooks.jsonl @tests/test_lab01_triage.py Run pytest and explain why 28 orders are bleeding margin and 35 VIP orders have phantom ATP.'</a:t>
             </a:r>
             <a:endParaRPr lang="en-US" sz="1100" b="0" u="none" strike="noStrike">
               <a:solidFill>
@@ -24631,7 +24895,7 @@
                 <a:uFillTx/>
                 <a:latin typeface="Arial"/>
               </a:rPr>
-              <a:t> '/plan Create a remediation plan for promo_pricing.py (GS1 GTIN-14, Decimal, multiplicative stackable promos, margin floor clamping) and inventory_atp.py (subtract reserved, safety_stock, and webhook delta).'</a:t>
+              <a:t> '/plan Create a remediation plan for promo_pricing.py (GS1 GTIN-14, Decimal, multiplicative stackable promos, margin floor clamping) and inventory_atp.py (subtract reserved, damaged_hold, bopis_lock, safety_stock, and unprocessed_pos_events).'</a:t>
             </a:r>
             <a:endParaRPr lang="en-US" sz="1100" b="0" u="none" strike="noStrike">
               <a:solidFill>
@@ -24693,7 +24957,7 @@
                 <a:uFillTx/>
                 <a:latin typeface="Courier New"/>
               </a:rPr>
-              <a:t>calculate_node_atp</a:t>
+              <a:t>calculate_true_atp</a:t>
             </a:r>
             <a:r>
               <a:rPr lang="en-US" sz="1100" b="0" u="none" strike="noStrike">
@@ -24726,7 +24990,7 @@
                 <a:uFillTx/>
                 <a:latin typeface="Arial"/>
               </a:rPr>
-              <a:t> -&gt; 'Subtract reserved_qty, safety_stock_qty, and unprocessed_webhook_delta_qty from on_hand_qty.'</a:t>
+              <a:t> -&gt; 'Subtract reserved_qty, damaged_hold_qty, bopis_lock_qty, safety_stock_qty, and unprocessed_pos_events from on_hand_qty.'</a:t>
             </a:r>
             <a:endParaRPr lang="en-US" sz="1100" b="0" u="none" strike="noStrike">
               <a:solidFill>
@@ -26555,7 +26819,7 @@
                 <a:uFillTx/>
                 <a:latin typeface="Courier New"/>
               </a:rPr>
-              <a:t>15%</a:t>
+              <a:t>margin_floor_pct</a:t>
             </a:r>
             <a:r>
               <a:rPr lang="en-US" sz="1100" b="0" u="none" strike="noStrike">
@@ -26566,7 +26830,7 @@
                 <a:uFillTx/>
                 <a:latin typeface="Arial"/>
               </a:rPr>
-              <a:t> margin floor, and OTIF chargeback formulas.</a:t>
+              <a:t>, and OTIF chargeback formulas.</a:t>
             </a:r>
             <a:endParaRPr lang="en-US" sz="1100" b="0" u="none" strike="noStrike">
               <a:solidFill>
@@ -26617,7 +26881,7 @@
                 <a:uFillTx/>
                 <a:latin typeface="Courier New"/>
               </a:rPr>
-              <a:t>.agents/skills/margin-otif-audit/SKILL.md</a:t>
+              <a:t>.agents/skills/retail-otif-margin-auditor/SKILL.md</a:t>
             </a:r>
             <a:r>
               <a:rPr lang="en-US" sz="1100" b="1" u="none" strike="noStrike">
@@ -26650,7 +26914,7 @@
                 <a:uFillTx/>
                 <a:latin typeface="Courier New"/>
               </a:rPr>
-              <a:t>name: margin-otif-audit</a:t>
+              <a:t>name: retail-otif-margin-auditor</a:t>
             </a:r>
             <a:r>
               <a:rPr lang="en-US" sz="1100" b="0" u="none" strike="noStrike">
@@ -26672,7 +26936,7 @@
                 <a:uFillTx/>
                 <a:latin typeface="Courier New"/>
               </a:rPr>
-              <a:t>scripts/run_otif_margin_audit.py</a:t>
+              <a:t>scripts/audit_vendor_otif.py</a:t>
             </a:r>
             <a:r>
               <a:rPr lang="en-US" sz="1100" b="0" u="none" strike="noStrike">
@@ -26745,7 +27009,7 @@
                 <a:uFillTx/>
                 <a:latin typeface="Courier New"/>
               </a:rPr>
-              <a:t>data/exports/executive_margin_otif_audit.json</a:t>
+              <a:t>data/exports/otif_chargeback_audit_report.json</a:t>
             </a:r>
             <a:r>
               <a:rPr lang="en-US" sz="1100" b="0" u="none" strike="noStrike">
@@ -26756,7 +27020,7 @@
                 <a:uFillTx/>
                 <a:latin typeface="Arial"/>
               </a:rPr>
-              <a:t> &amp; </a:t>
+              <a:t> (</a:t>
             </a:r>
             <a:r>
               <a:rPr lang="en-US" sz="1100" b="1" u="none" strike="noStrike">
@@ -26767,7 +27031,7 @@
                 <a:uFillTx/>
                 <a:latin typeface="Courier New"/>
               </a:rPr>
-              <a:t>.md</a:t>
+              <a:t>$98,250.00</a:t>
             </a:r>
             <a:r>
               <a:rPr lang="en-US" sz="1100" b="0" u="none" strike="noStrike">
@@ -26778,7 +27042,7 @@
                 <a:uFillTx/>
                 <a:latin typeface="Arial"/>
               </a:rPr>
-              <a:t> (</a:t>
+              <a:t> OTIF chargebacks across 6 suppliers) and pass all 4 Lab 02 tests (</a:t>
             </a:r>
             <a:r>
               <a:rPr lang="en-US" sz="1100" b="1" u="none" strike="noStrike">
@@ -26789,7 +27053,7 @@
                 <a:uFillTx/>
                 <a:latin typeface="Courier New"/>
               </a:rPr>
-              <a:t>$98,250.00</a:t>
+              <a:t>10 passed</a:t>
             </a:r>
             <a:r>
               <a:rPr lang="en-US" sz="1100" b="0" u="none" strike="noStrike">
@@ -26800,7 +27064,7 @@
                 <a:uFillTx/>
                 <a:latin typeface="Arial"/>
               </a:rPr>
-              <a:t> OTIF chargebacks) and pass </a:t>
+              <a:t> cumulative) in </a:t>
             </a:r>
             <a:r>
               <a:rPr lang="en-US" sz="1100" b="1" u="none" strike="noStrike">
@@ -27843,7 +28107,7 @@
                 <a:uFillTx/>
                 <a:latin typeface="Courier New"/>
               </a:rPr>
-              <a:t>on_hand - reserved - safety_stock - webhook_delta</a:t>
+              <a:t>on_hand - reserved - damaged_hold - bopis_lock - safety_stock - unprocessed_pos_events</a:t>
             </a:r>
             <a:r>
               <a:rPr lang="en-US" sz="1100" b="0" u="none" strike="noStrike">
@@ -27905,7 +28169,7 @@
                 <a:uFillTx/>
                 <a:latin typeface="Courier New"/>
               </a:rPr>
-              <a:t>.agents/skills/margin-otif-audit/SKILL.md</a:t>
+              <a:t>.agents/skills/retail-otif-margin-auditor/SKILL.md</a:t>
             </a:r>
             <a:r>
               <a:rPr lang="en-US" sz="1100" b="1" u="none" strike="noStrike">
@@ -27938,7 +28202,7 @@
                 <a:uFillTx/>
                 <a:latin typeface="Courier New"/>
               </a:rPr>
-              <a:t>name: margin-otif-audit</a:t>
+              <a:t>name: retail-otif-margin-auditor</a:t>
             </a:r>
             <a:r>
               <a:rPr lang="en-US" sz="1100" b="0" u="none" strike="noStrike">
@@ -27982,7 +28246,7 @@
                 <a:uFillTx/>
                 <a:latin typeface="Courier New"/>
               </a:rPr>
-              <a:t>./.venv/bin/python scripts/run_otif_margin_audit.py</a:t>
+              <a:t>./.venv/bin/python scripts/audit_vendor_otif.py</a:t>
             </a:r>
             <a:r>
               <a:rPr lang="en-US" sz="1100" b="0" u="none" strike="noStrike">
@@ -28077,7 +28341,7 @@
                 <a:uFillTx/>
                 <a:latin typeface="Courier New"/>
               </a:rPr>
-              <a:t>5 passed</a:t>
+              <a:t>10 passed</a:t>
             </a:r>
             <a:r>
               <a:rPr lang="en-US" sz="1100" b="0" u="none" strike="noStrike">
@@ -28088,7 +28352,29 @@
                 <a:uFillTx/>
                 <a:latin typeface="Arial"/>
               </a:rPr>
-              <a:t> + executive OTIF/margin reports generated).</a:t>
+              <a:t> cumulative + </a:t>
+            </a:r>
+            <a:r>
+              <a:rPr lang="en-US" sz="1100" b="1" u="none" strike="noStrike">
+                <a:solidFill>
+                  <a:srgbClr val="20E3B2"/>
+                </a:solidFill>
+                <a:effectLst/>
+                <a:uFillTx/>
+                <a:latin typeface="Courier New"/>
+              </a:rPr>
+              <a:t>data/exports/otif_chargeback_audit_report.json</a:t>
+            </a:r>
+            <a:r>
+              <a:rPr lang="en-US" sz="1100" b="0" u="none" strike="noStrike">
+                <a:solidFill>
+                  <a:srgbClr val="F0F6FC"/>
+                </a:solidFill>
+                <a:effectLst/>
+                <a:uFillTx/>
+                <a:latin typeface="Arial"/>
+              </a:rPr>
+              <a:t> generated).</a:t>
             </a:r>
             <a:endParaRPr lang="en-US" sz="1100" b="0" u="none" strike="noStrike">
               <a:solidFill>
@@ -28317,7 +28603,7 @@
                 <a:uFillTx/>
                 <a:latin typeface="Arial"/>
               </a:rPr>
-              <a:t> '/plan Create @GEMINI.md and @.agents/rules/retail-standards.md enforcing Decimal ROUND_HALF_UP, GS1 GTIN-14 Modulo-10 validation, True ATP webhook delta deductions, multiplicative promo stacking, and OTIF chargeback rules.'</a:t>
+              <a:t> '/plan Create @GEMINI.md and @.agents/rules/retail-standards.md enforcing Decimal ROUND_HALF_UP, GS1 GTIN-14 Modulo-10 validation, True ATP deductions, multiplicative promo stacking, and OTIF chargeback rules.'</a:t>
             </a:r>
             <a:endParaRPr lang="en-US" sz="1100" b="0" u="none" strike="noStrike">
               <a:solidFill>
@@ -28368,7 +28654,7 @@
                 <a:uFillTx/>
                 <a:latin typeface="Arial"/>
               </a:rPr>
-              <a:t> 'Create @.agents/skills/margin-otif-audit/SKILL.md with YAML frontmatter (name: margin-otif-audit) that executes ./scripts/run_otif_margin_audit.py and writes data/exports/executive_margin_otif_audit.json and .md.'</a:t>
+              <a:t> 'Create @.agents/skills/retail-otif-margin-auditor/SKILL.md with YAML frontmatter (name: retail-otif-margin-auditor) that executes ./.venv/bin/python scripts/audit_vendor_otif.py and writes data/exports/otif_chargeback_audit_report.json.'</a:t>
             </a:r>
             <a:endParaRPr lang="en-US" sz="1100" b="0" u="none" strike="noStrike">
               <a:solidFill>

</xml_diff>